<commit_message>
Handover, plan and explanation file reconciled with the 30-slide deck; note 26 and the plan's student timeline brought up to date
Co-Authored-By: Claude Fable 5.1 <noreply@anthropic.com>
Claude-Session: https://claude.ai/code/session_016LhpG4kT7Z7ppxbG4TW5S9
</commit_message>
<xml_diff>
--- a/docs/supervisor_update_2026-10-19.pptx
+++ b/docs/supervisor_update_2026-10-19.pptx
@@ -136,28 +136,28 @@
   <p:extLst>
     <p:ext uri="{521415D9-36F7-43E2-AB2F-B90AF26B5E84}">
       <p14:sectionLst xmlns:p14="http://schemas.microsoft.com/office/powerpoint/2010/main">
-        <p14:section name="Overview" id="{73027aff-c746-4414-ee17-a1e862bdf544}">
+        <p14:section name="Overview" id="{966bbb58-6e92-104e-50a3-b9c98ae78f56}">
           <p14:sldIdLst>
             <p14:sldId id="256"/>
             <p14:sldId id="257"/>
             <p14:sldId id="258"/>
           </p14:sldIdLst>
         </p14:section>
-        <p14:section name="Data" id="{d0c95eb2-05e8-90d0-45e6-88722ca0d6c1}">
+        <p14:section name="Data" id="{d5d2e030-6525-fe79-3546-2f6fbffe4dae}">
           <p14:sldIdLst>
             <p14:sldId id="259"/>
             <p14:sldId id="260"/>
             <p14:sldId id="261"/>
           </p14:sldIdLst>
         </p14:section>
-        <p14:section name="Training" id="{e6a5bce3-7a10-90f2-c25e-ca98b3767999}">
+        <p14:section name="Training" id="{b9e5c24d-0955-ce71-c981-9a23901b9e29}">
           <p14:sldIdLst>
             <p14:sldId id="262"/>
             <p14:sldId id="263"/>
             <p14:sldId id="264"/>
           </p14:sldIdLst>
         </p14:section>
-        <p14:section name="Findings and fixes" id="{f21bd26d-1e7f-1dc5-5a56-7007e7f84bc8}">
+        <p14:section name="Findings and fixes" id="{4979f280-a622-3610-08d1-8c17af989e3e}">
           <p14:sldIdLst>
             <p14:sldId id="265"/>
             <p14:sldId id="266"/>
@@ -171,13 +171,13 @@
             <p14:sldId id="274"/>
           </p14:sldIdLst>
         </p14:section>
-        <p14:section name="Final model" id="{48dd9161-2244-c313-4239-c18f34fa5e4e}">
+        <p14:section name="Final model" id="{8f086013-add3-091f-a8c8-3e94c32983af}">
           <p14:sldIdLst>
             <p14:sldId id="275"/>
             <p14:sldId id="276"/>
           </p14:sldIdLst>
         </p14:section>
-        <p14:section name="Requirements and plan" id="{37e950bc-abd8-8284-0f04-6879cd327e52}">
+        <p14:section name="Requirements and plan" id="{e8803230-ef18-6f43-0a6d-4e771a3107b0}">
           <p14:sldIdLst>
             <p14:sldId id="277"/>
             <p14:sldId id="278"/>
@@ -186,7 +186,7 @@
             <p14:sldId id="281"/>
           </p14:sldIdLst>
         </p14:section>
-        <p14:section name="Appendix" id="{7f3cdbad-d116-accb-6635-ab8730510b16}">
+        <p14:section name="Appendix" id="{18e424a8-e55c-5c91-6cb4-1833656f72e7}">
           <p14:sldIdLst>
             <p14:sldId id="282"/>
             <p14:sldId id="283"/>
@@ -2449,7 +2449,7 @@
           <a:p>
             <a:r>
               <a:rPr lang="en-US" dirty="0"/>
-              <a:t>- Both options: either fine-tune should also mask the 3DPW finger labels, which are set to the rest pose, with mask_3dpw_hands; the final model does. A new flag can also leave out the eight 3DPW shape values that are constants, age 0.55 and seven at 0.5; it is off by default and off in the final model; a run with it on is in progress (slide 18). With it on, the 3DPW error can change for a reason unrelated to the two fixes.</a:t>
+              <a:t>- Both options: either fine-tune should also mask the 3DPW finger labels, which are set to the rest pose, with mask_3dpw_hands; the final model does. A new flag can also leave out the eight 3DPW shape values that are constants, age 0.55 and seven at 0.5; it is off by default and off in the final model; a run with it on is done (slide 19): body variety on photos opens, gender and children fall back; a partial mask that keeps age is queued (job 3614042). With it on, the 3DPW error can change for a reason unrelated to the two fixes.</a:t>
             </a:r>
           </a:p>
         </p:txBody>

</xml_diff>